<commit_message>
docs(presentation): label the assessment budget
Show the EUR 5 alert budget in the visible assessment footer while keeping the production model plane governed by SLO, measured load, regional quota, and FinOps approval.

This closes the final product-level review finding without changing slide geometry, theme, or production capacity guidance.
</commit_message>
<xml_diff>
--- a/presentation/siemens-senior-ai-engineer-test.pptx
+++ b/presentation/siemens-senior-ai-engineer-test.pptx
@@ -2,28 +2,28 @@
 <file path=ppt/presentation.xml><?xml version="1.0" encoding="utf-8"?>
 <p:presentation xmlns:p="http://schemas.openxmlformats.org/presentationml/2006/main">
   <p:sldMasterIdLst>
-    <p:sldMasterId xmlns:r="http://schemas.openxmlformats.org/officeDocument/2006/relationships" id="2147483648" r:id="Rc1f234b67ddc46a1"/>
+    <p:sldMasterId xmlns:r="http://schemas.openxmlformats.org/officeDocument/2006/relationships" id="2147483648" r:id="R2c5924d757c3427b"/>
   </p:sldMasterIdLst>
   <p:notesMasterIdLst>
-    <p:notesMasterId xmlns:r="http://schemas.openxmlformats.org/officeDocument/2006/relationships" r:id="R742bbafaf58d4447"/>
+    <p:notesMasterId xmlns:r="http://schemas.openxmlformats.org/officeDocument/2006/relationships" r:id="R721a9b522be74e15"/>
   </p:notesMasterIdLst>
   <p:sldIdLst>
-    <p:sldId xmlns:r="http://schemas.openxmlformats.org/officeDocument/2006/relationships" id="256" r:id="R7096eda3eb0048ef"/>
-    <p:sldId xmlns:r="http://schemas.openxmlformats.org/officeDocument/2006/relationships" id="257" r:id="Rd2ecf39c5cd144d0"/>
-    <p:sldId xmlns:r="http://schemas.openxmlformats.org/officeDocument/2006/relationships" id="258" r:id="R82b1077c50034fc3"/>
-    <p:sldId xmlns:r="http://schemas.openxmlformats.org/officeDocument/2006/relationships" id="259" r:id="R4f4987bb90ef4d85"/>
-    <p:sldId xmlns:r="http://schemas.openxmlformats.org/officeDocument/2006/relationships" id="260" r:id="R26ed4d29c3514289"/>
-    <p:sldId xmlns:r="http://schemas.openxmlformats.org/officeDocument/2006/relationships" id="261" r:id="R5463edc7def948af"/>
-    <p:sldId xmlns:r="http://schemas.openxmlformats.org/officeDocument/2006/relationships" id="262" r:id="R5aa19721ffde4fe9"/>
-    <p:sldId xmlns:r="http://schemas.openxmlformats.org/officeDocument/2006/relationships" id="263" r:id="R9820e6b7a1404b53"/>
-    <p:sldId xmlns:r="http://schemas.openxmlformats.org/officeDocument/2006/relationships" id="264" r:id="R0e06b07c39764a3d"/>
-    <p:sldId xmlns:r="http://schemas.openxmlformats.org/officeDocument/2006/relationships" id="265" r:id="R0cdfd4ab6c2c4e4e"/>
-    <p:sldId xmlns:r="http://schemas.openxmlformats.org/officeDocument/2006/relationships" id="266" r:id="Rfc4981419a5243e0"/>
-    <p:sldId xmlns:r="http://schemas.openxmlformats.org/officeDocument/2006/relationships" id="267" r:id="R177861f01fae4a3a"/>
-    <p:sldId xmlns:r="http://schemas.openxmlformats.org/officeDocument/2006/relationships" id="268" r:id="R4c4bc85dd0ba4de5"/>
-    <p:sldId xmlns:r="http://schemas.openxmlformats.org/officeDocument/2006/relationships" id="269" r:id="Re3e20ab79f9043b4"/>
-    <p:sldId xmlns:r="http://schemas.openxmlformats.org/officeDocument/2006/relationships" id="270" r:id="R25437bea09904f79"/>
-    <p:sldId xmlns:r="http://schemas.openxmlformats.org/officeDocument/2006/relationships" id="271" r:id="R487b1d114a664831"/>
+    <p:sldId xmlns:r="http://schemas.openxmlformats.org/officeDocument/2006/relationships" id="256" r:id="R798eb3f5876b46ed"/>
+    <p:sldId xmlns:r="http://schemas.openxmlformats.org/officeDocument/2006/relationships" id="257" r:id="R0a67b552559749ca"/>
+    <p:sldId xmlns:r="http://schemas.openxmlformats.org/officeDocument/2006/relationships" id="258" r:id="R01e3c6242f1245bc"/>
+    <p:sldId xmlns:r="http://schemas.openxmlformats.org/officeDocument/2006/relationships" id="259" r:id="R48979ed69af14ae9"/>
+    <p:sldId xmlns:r="http://schemas.openxmlformats.org/officeDocument/2006/relationships" id="260" r:id="Rbfc4076da39e4d1c"/>
+    <p:sldId xmlns:r="http://schemas.openxmlformats.org/officeDocument/2006/relationships" id="261" r:id="Re99a0ab2bed34578"/>
+    <p:sldId xmlns:r="http://schemas.openxmlformats.org/officeDocument/2006/relationships" id="262" r:id="R9413d16e6f0f4127"/>
+    <p:sldId xmlns:r="http://schemas.openxmlformats.org/officeDocument/2006/relationships" id="263" r:id="R402e133c7bb347c7"/>
+    <p:sldId xmlns:r="http://schemas.openxmlformats.org/officeDocument/2006/relationships" id="264" r:id="Re74b987f8b9248b8"/>
+    <p:sldId xmlns:r="http://schemas.openxmlformats.org/officeDocument/2006/relationships" id="265" r:id="R34fd7d9947aa4710"/>
+    <p:sldId xmlns:r="http://schemas.openxmlformats.org/officeDocument/2006/relationships" id="266" r:id="R590ce96306c2452a"/>
+    <p:sldId xmlns:r="http://schemas.openxmlformats.org/officeDocument/2006/relationships" id="267" r:id="R472ec27c2d6c4fb0"/>
+    <p:sldId xmlns:r="http://schemas.openxmlformats.org/officeDocument/2006/relationships" id="268" r:id="R476a03534b4a47de"/>
+    <p:sldId xmlns:r="http://schemas.openxmlformats.org/officeDocument/2006/relationships" id="269" r:id="Ra603076f334c46d0"/>
+    <p:sldId xmlns:r="http://schemas.openxmlformats.org/officeDocument/2006/relationships" id="270" r:id="Ra21de41966f44b04"/>
+    <p:sldId xmlns:r="http://schemas.openxmlformats.org/officeDocument/2006/relationships" id="271" r:id="Rac3b1492ee6c4087"/>
   </p:sldIdLst>
   <p:sldSz cx="12191695" cy="6858000"/>
   <p:notesSz cx="6858000" cy="9144000"/>
@@ -1615,7 +1615,7 @@
   </p:cSld>
   <p:clrMap bg1="lt1" tx1="dk1" bg2="lt2" tx2="dk2" accent1="accent1" accent2="accent2" accent3="accent3" accent4="accent4" accent5="accent5" accent6="accent6" hlink="hlink" folHlink="folHlink"/>
   <p:sldLayoutIdLst>
-    <p:sldLayoutId xmlns:r="http://schemas.openxmlformats.org/officeDocument/2006/relationships" id="2147483649" r:id="R56d91311d57b49ea"/>
+    <p:sldLayoutId xmlns:r="http://schemas.openxmlformats.org/officeDocument/2006/relationships" id="2147483649" r:id="Rc7ab461994354a4e"/>
   </p:sldLayoutIdLst>
   <p:hf sldNum="0" hdr="0" ftr="0" dt="0"/>
   <p:txStyles>
@@ -2354,10 +2354,10 @@
           <p:nvPr/>
         </p:nvPicPr>
         <p:blipFill>
-          <a:blip xmlns:r="http://schemas.openxmlformats.org/officeDocument/2006/relationships" xmlns:a="http://schemas.openxmlformats.org/drawingml/2006/main" r:embed="R9d40033979334855">
+          <a:blip xmlns:r="http://schemas.openxmlformats.org/officeDocument/2006/relationships" xmlns:a="http://schemas.openxmlformats.org/drawingml/2006/main" r:embed="Rc55a46f0319e4a97">
             <a:extLst>
               <a:ext uri="{96DAC541-7B7A-43D3-8B79-37D633B846F1}">
-                <asvg:svgBlip xmlns:asvg="http://schemas.microsoft.com/office/drawing/2016/SVG/main" r:embed="R495cb5d66fd4486a"/>
+                <asvg:svgBlip xmlns:asvg="http://schemas.microsoft.com/office/drawing/2016/SVG/main" r:embed="R4c6126597e4742f2"/>
               </a:ext>
             </a:extLst>
           </a:blip>
@@ -3029,10 +3029,10 @@
           <p:nvPr/>
         </p:nvPicPr>
         <p:blipFill>
-          <a:blip xmlns:r="http://schemas.openxmlformats.org/officeDocument/2006/relationships" xmlns:a="http://schemas.openxmlformats.org/drawingml/2006/main" r:embed="R35d21737c2cd41c3">
+          <a:blip xmlns:r="http://schemas.openxmlformats.org/officeDocument/2006/relationships" xmlns:a="http://schemas.openxmlformats.org/drawingml/2006/main" r:embed="R721d371717334ae3">
             <a:extLst>
               <a:ext uri="{96DAC541-7B7A-43D3-8B79-37D633B846F1}">
-                <asvg:svgBlip xmlns:asvg="http://schemas.microsoft.com/office/drawing/2016/SVG/main" r:embed="Rde1352a731a44bc9"/>
+                <asvg:svgBlip xmlns:asvg="http://schemas.microsoft.com/office/drawing/2016/SVG/main" r:embed="Reeaa80ca46e24e3b"/>
               </a:ext>
             </a:extLst>
           </a:blip>
@@ -3234,10 +3234,10 @@
           <p:nvPr/>
         </p:nvPicPr>
         <p:blipFill>
-          <a:blip xmlns:r="http://schemas.openxmlformats.org/officeDocument/2006/relationships" xmlns:a="http://schemas.openxmlformats.org/drawingml/2006/main" r:embed="R6c391170e23e45a6">
+          <a:blip xmlns:r="http://schemas.openxmlformats.org/officeDocument/2006/relationships" xmlns:a="http://schemas.openxmlformats.org/drawingml/2006/main" r:embed="R67997cb97c9b4836">
             <a:extLst>
               <a:ext uri="{96DAC541-7B7A-43D3-8B79-37D633B846F1}">
-                <asvg:svgBlip xmlns:asvg="http://schemas.microsoft.com/office/drawing/2016/SVG/main" r:embed="R7b370a56ea394bf2"/>
+                <asvg:svgBlip xmlns:asvg="http://schemas.microsoft.com/office/drawing/2016/SVG/main" r:embed="R85d45102c237495f"/>
               </a:ext>
             </a:extLst>
           </a:blip>
@@ -3514,10 +3514,10 @@
           <p:nvPr/>
         </p:nvPicPr>
         <p:blipFill>
-          <a:blip xmlns:r="http://schemas.openxmlformats.org/officeDocument/2006/relationships" xmlns:a="http://schemas.openxmlformats.org/drawingml/2006/main" r:embed="R905a4991cc824e86">
+          <a:blip xmlns:r="http://schemas.openxmlformats.org/officeDocument/2006/relationships" xmlns:a="http://schemas.openxmlformats.org/drawingml/2006/main" r:embed="R988496ec8aec4d80">
             <a:extLst>
               <a:ext uri="{96DAC541-7B7A-43D3-8B79-37D633B846F1}">
-                <asvg:svgBlip xmlns:asvg="http://schemas.microsoft.com/office/drawing/2016/SVG/main" r:embed="Rd6edd707281f47fd"/>
+                <asvg:svgBlip xmlns:asvg="http://schemas.microsoft.com/office/drawing/2016/SVG/main" r:embed="Rb2d31e1f76464e53"/>
               </a:ext>
             </a:extLst>
           </a:blip>
@@ -3621,10 +3621,10 @@
           <p:nvPr/>
         </p:nvPicPr>
         <p:blipFill>
-          <a:blip xmlns:r="http://schemas.openxmlformats.org/officeDocument/2006/relationships" xmlns:a="http://schemas.openxmlformats.org/drawingml/2006/main" r:embed="R7fa72188d73241aa">
+          <a:blip xmlns:r="http://schemas.openxmlformats.org/officeDocument/2006/relationships" xmlns:a="http://schemas.openxmlformats.org/drawingml/2006/main" r:embed="R1df1d6bdb3b44224">
             <a:extLst>
               <a:ext uri="{96DAC541-7B7A-43D3-8B79-37D633B846F1}">
-                <asvg:svgBlip xmlns:asvg="http://schemas.microsoft.com/office/drawing/2016/SVG/main" r:embed="R884c9681a8884c3a"/>
+                <asvg:svgBlip xmlns:asvg="http://schemas.microsoft.com/office/drawing/2016/SVG/main" r:embed="R05aa31709c5d48ae"/>
               </a:ext>
             </a:extLst>
           </a:blip>
@@ -3826,10 +3826,10 @@
           <p:nvPr/>
         </p:nvPicPr>
         <p:blipFill>
-          <a:blip xmlns:r="http://schemas.openxmlformats.org/officeDocument/2006/relationships" xmlns:a="http://schemas.openxmlformats.org/drawingml/2006/main" r:embed="R1cef24726f964666">
+          <a:blip xmlns:r="http://schemas.openxmlformats.org/officeDocument/2006/relationships" xmlns:a="http://schemas.openxmlformats.org/drawingml/2006/main" r:embed="R2bc6a005562c4a3b">
             <a:extLst>
               <a:ext uri="{96DAC541-7B7A-43D3-8B79-37D633B846F1}">
-                <asvg:svgBlip xmlns:asvg="http://schemas.microsoft.com/office/drawing/2016/SVG/main" r:embed="Rc9922273ce9e45c8"/>
+                <asvg:svgBlip xmlns:asvg="http://schemas.microsoft.com/office/drawing/2016/SVG/main" r:embed="Raf8fa3c1296f4a39"/>
               </a:ext>
             </a:extLst>
           </a:blip>
@@ -4443,10 +4443,10 @@
           <p:nvPr/>
         </p:nvPicPr>
         <p:blipFill>
-          <a:blip xmlns:r="http://schemas.openxmlformats.org/officeDocument/2006/relationships" xmlns:a="http://schemas.openxmlformats.org/drawingml/2006/main" r:embed="R38912df44e594595">
+          <a:blip xmlns:r="http://schemas.openxmlformats.org/officeDocument/2006/relationships" xmlns:a="http://schemas.openxmlformats.org/drawingml/2006/main" r:embed="Re9f1c931712f4e52">
             <a:extLst>
               <a:ext uri="{96DAC541-7B7A-43D3-8B79-37D633B846F1}">
-                <asvg:svgBlip xmlns:asvg="http://schemas.microsoft.com/office/drawing/2016/SVG/main" r:embed="R5f9e0bb424994776"/>
+                <asvg:svgBlip xmlns:asvg="http://schemas.microsoft.com/office/drawing/2016/SVG/main" r:embed="R81e1a125f9434d42"/>
               </a:ext>
             </a:extLst>
           </a:blip>
@@ -4626,10 +4626,10 @@
           <p:nvPr/>
         </p:nvPicPr>
         <p:blipFill>
-          <a:blip xmlns:r="http://schemas.openxmlformats.org/officeDocument/2006/relationships" xmlns:a="http://schemas.openxmlformats.org/drawingml/2006/main" r:embed="Rf2d3f8ab56b646e0">
+          <a:blip xmlns:r="http://schemas.openxmlformats.org/officeDocument/2006/relationships" xmlns:a="http://schemas.openxmlformats.org/drawingml/2006/main" r:embed="R7e66996e022f49f8">
             <a:extLst>
               <a:ext uri="{96DAC541-7B7A-43D3-8B79-37D633B846F1}">
-                <asvg:svgBlip xmlns:asvg="http://schemas.microsoft.com/office/drawing/2016/SVG/main" r:embed="Raa2c0882516347ef"/>
+                <asvg:svgBlip xmlns:asvg="http://schemas.microsoft.com/office/drawing/2016/SVG/main" r:embed="R26bf4dfbba214b49"/>
               </a:ext>
             </a:extLst>
           </a:blip>
@@ -4975,10 +4975,10 @@
           <p:nvPr/>
         </p:nvPicPr>
         <p:blipFill>
-          <a:blip xmlns:r="http://schemas.openxmlformats.org/officeDocument/2006/relationships" xmlns:a="http://schemas.openxmlformats.org/drawingml/2006/main" r:embed="R00a15abdf1b847cb">
+          <a:blip xmlns:r="http://schemas.openxmlformats.org/officeDocument/2006/relationships" xmlns:a="http://schemas.openxmlformats.org/drawingml/2006/main" r:embed="R0d497a5afde145ba">
             <a:extLst>
               <a:ext uri="{96DAC541-7B7A-43D3-8B79-37D633B846F1}">
-                <asvg:svgBlip xmlns:asvg="http://schemas.microsoft.com/office/drawing/2016/SVG/main" r:embed="R8f9231d0d51347d2"/>
+                <asvg:svgBlip xmlns:asvg="http://schemas.microsoft.com/office/drawing/2016/SVG/main" r:embed="R0099066a448d43ff"/>
               </a:ext>
             </a:extLst>
           </a:blip>
@@ -5634,10 +5634,10 @@
           <p:nvPr/>
         </p:nvPicPr>
         <p:blipFill>
-          <a:blip xmlns:r="http://schemas.openxmlformats.org/officeDocument/2006/relationships" xmlns:a="http://schemas.openxmlformats.org/drawingml/2006/main" r:embed="R1ade316847cd46b1">
+          <a:blip xmlns:r="http://schemas.openxmlformats.org/officeDocument/2006/relationships" xmlns:a="http://schemas.openxmlformats.org/drawingml/2006/main" r:embed="R0f785a9ac3c84904">
             <a:extLst>
               <a:ext uri="{96DAC541-7B7A-43D3-8B79-37D633B846F1}">
-                <asvg:svgBlip xmlns:asvg="http://schemas.microsoft.com/office/drawing/2016/SVG/main" r:embed="R898171e857c14814"/>
+                <asvg:svgBlip xmlns:asvg="http://schemas.microsoft.com/office/drawing/2016/SVG/main" r:embed="Rf1c172aa27c249d9"/>
               </a:ext>
             </a:extLst>
           </a:blip>
@@ -5664,10 +5664,10 @@
           <p:nvPr/>
         </p:nvPicPr>
         <p:blipFill>
-          <a:blip xmlns:r="http://schemas.openxmlformats.org/officeDocument/2006/relationships" xmlns:a="http://schemas.openxmlformats.org/drawingml/2006/main" r:embed="R49abeedefe11484d">
+          <a:blip xmlns:r="http://schemas.openxmlformats.org/officeDocument/2006/relationships" xmlns:a="http://schemas.openxmlformats.org/drawingml/2006/main" r:embed="R5514d63370c5424e">
             <a:extLst>
               <a:ext uri="{96DAC541-7B7A-43D3-8B79-37D633B846F1}">
-                <asvg:svgBlip xmlns:asvg="http://schemas.microsoft.com/office/drawing/2016/SVG/main" r:embed="R4d6de6e314c54361"/>
+                <asvg:svgBlip xmlns:asvg="http://schemas.microsoft.com/office/drawing/2016/SVG/main" r:embed="R19f3e9d60f424ab4"/>
               </a:ext>
             </a:extLst>
           </a:blip>
@@ -5694,10 +5694,10 @@
           <p:nvPr/>
         </p:nvPicPr>
         <p:blipFill>
-          <a:blip xmlns:r="http://schemas.openxmlformats.org/officeDocument/2006/relationships" xmlns:a="http://schemas.openxmlformats.org/drawingml/2006/main" r:embed="Rbe857cc7f88449f9">
+          <a:blip xmlns:r="http://schemas.openxmlformats.org/officeDocument/2006/relationships" xmlns:a="http://schemas.openxmlformats.org/drawingml/2006/main" r:embed="R085fe260d5af46da">
             <a:extLst>
               <a:ext uri="{96DAC541-7B7A-43D3-8B79-37D633B846F1}">
-                <asvg:svgBlip xmlns:asvg="http://schemas.microsoft.com/office/drawing/2016/SVG/main" r:embed="Ra7d055c4971f4b93"/>
+                <asvg:svgBlip xmlns:asvg="http://schemas.microsoft.com/office/drawing/2016/SVG/main" r:embed="Ree494df51b584b0e"/>
               </a:ext>
             </a:extLst>
           </a:blip>
@@ -5724,7 +5724,7 @@
           <p:nvPr/>
         </p:nvPicPr>
         <p:blipFill>
-          <a:blip xmlns:r="http://schemas.openxmlformats.org/officeDocument/2006/relationships" xmlns:a="http://schemas.openxmlformats.org/drawingml/2006/main" r:embed="R75a7e006310a4bed"/>
+          <a:blip xmlns:r="http://schemas.openxmlformats.org/officeDocument/2006/relationships" xmlns:a="http://schemas.openxmlformats.org/drawingml/2006/main" r:embed="Ree7b6abe66aa4c97"/>
           <a:stretch xmlns:a="http://schemas.openxmlformats.org/drawingml/2006/main">
             <a:fillRect l="0" t="0" r="0" b="0"/>
           </a:stretch>
@@ -5748,10 +5748,10 @@
           <p:nvPr/>
         </p:nvPicPr>
         <p:blipFill>
-          <a:blip xmlns:r="http://schemas.openxmlformats.org/officeDocument/2006/relationships" xmlns:a="http://schemas.openxmlformats.org/drawingml/2006/main" r:embed="R75a7e006310a4bed">
+          <a:blip xmlns:r="http://schemas.openxmlformats.org/officeDocument/2006/relationships" xmlns:a="http://schemas.openxmlformats.org/drawingml/2006/main" r:embed="Ree7b6abe66aa4c97">
             <a:extLst>
               <a:ext uri="{96DAC541-7B7A-43D3-8B79-37D633B846F1}">
-                <asvg:svgBlip xmlns:asvg="http://schemas.microsoft.com/office/drawing/2016/SVG/main" r:embed="R6d19542e9e264a79"/>
+                <asvg:svgBlip xmlns:asvg="http://schemas.microsoft.com/office/drawing/2016/SVG/main" r:embed="R2e18066c72634a2e"/>
               </a:ext>
             </a:extLst>
           </a:blip>
@@ -5778,10 +5778,10 @@
           <p:nvPr/>
         </p:nvPicPr>
         <p:blipFill>
-          <a:blip xmlns:r="http://schemas.openxmlformats.org/officeDocument/2006/relationships" xmlns:a="http://schemas.openxmlformats.org/drawingml/2006/main" r:embed="Rb83349ad375d46d2">
+          <a:blip xmlns:r="http://schemas.openxmlformats.org/officeDocument/2006/relationships" xmlns:a="http://schemas.openxmlformats.org/drawingml/2006/main" r:embed="R1fdeafaa852843e6">
             <a:extLst>
               <a:ext uri="{96DAC541-7B7A-43D3-8B79-37D633B846F1}">
-                <asvg:svgBlip xmlns:asvg="http://schemas.microsoft.com/office/drawing/2016/SVG/main" r:embed="R86a519ffa7c845ef"/>
+                <asvg:svgBlip xmlns:asvg="http://schemas.microsoft.com/office/drawing/2016/SVG/main" r:embed="Rbff4a242b9d243bc"/>
               </a:ext>
             </a:extLst>
           </a:blip>
@@ -5808,7 +5808,7 @@
           <p:nvPr/>
         </p:nvPicPr>
         <p:blipFill>
-          <a:blip xmlns:r="http://schemas.openxmlformats.org/officeDocument/2006/relationships" xmlns:a="http://schemas.openxmlformats.org/drawingml/2006/main" r:embed="R7b417b74514a4488"/>
+          <a:blip xmlns:r="http://schemas.openxmlformats.org/officeDocument/2006/relationships" xmlns:a="http://schemas.openxmlformats.org/drawingml/2006/main" r:embed="R353e8bbae9f04f6c"/>
           <a:stretch xmlns:a="http://schemas.openxmlformats.org/drawingml/2006/main">
             <a:fillRect l="0" t="0" r="0" b="0"/>
           </a:stretch>
@@ -5832,10 +5832,10 @@
           <p:nvPr/>
         </p:nvPicPr>
         <p:blipFill>
-          <a:blip xmlns:r="http://schemas.openxmlformats.org/officeDocument/2006/relationships" xmlns:a="http://schemas.openxmlformats.org/drawingml/2006/main" r:embed="Rae80771d506743e9">
+          <a:blip xmlns:r="http://schemas.openxmlformats.org/officeDocument/2006/relationships" xmlns:a="http://schemas.openxmlformats.org/drawingml/2006/main" r:embed="R353e8bbae9f04f6c">
             <a:extLst>
               <a:ext uri="{96DAC541-7B7A-43D3-8B79-37D633B846F1}">
-                <asvg:svgBlip xmlns:asvg="http://schemas.microsoft.com/office/drawing/2016/SVG/main" r:embed="Rb76f97260c614467"/>
+                <asvg:svgBlip xmlns:asvg="http://schemas.microsoft.com/office/drawing/2016/SVG/main" r:embed="R9a94c698957d4f00"/>
               </a:ext>
             </a:extLst>
           </a:blip>
@@ -5862,10 +5862,10 @@
           <p:nvPr/>
         </p:nvPicPr>
         <p:blipFill>
-          <a:blip xmlns:r="http://schemas.openxmlformats.org/officeDocument/2006/relationships" xmlns:a="http://schemas.openxmlformats.org/drawingml/2006/main" r:embed="R7b417b74514a4488">
+          <a:blip xmlns:r="http://schemas.openxmlformats.org/officeDocument/2006/relationships" xmlns:a="http://schemas.openxmlformats.org/drawingml/2006/main" r:embed="R7240b0400ed7401d">
             <a:extLst>
               <a:ext uri="{96DAC541-7B7A-43D3-8B79-37D633B846F1}">
-                <asvg:svgBlip xmlns:asvg="http://schemas.microsoft.com/office/drawing/2016/SVG/main" r:embed="R6772a1c789184fbb"/>
+                <asvg:svgBlip xmlns:asvg="http://schemas.microsoft.com/office/drawing/2016/SVG/main" r:embed="R7822e1faf8aa4d0c"/>
               </a:ext>
             </a:extLst>
           </a:blip>
@@ -5892,7 +5892,7 @@
           <p:nvPr/>
         </p:nvPicPr>
         <p:blipFill>
-          <a:blip xmlns:r="http://schemas.openxmlformats.org/officeDocument/2006/relationships" xmlns:a="http://schemas.openxmlformats.org/drawingml/2006/main" r:embed="R233baec7b7d74fff"/>
+          <a:blip xmlns:r="http://schemas.openxmlformats.org/officeDocument/2006/relationships" xmlns:a="http://schemas.openxmlformats.org/drawingml/2006/main" r:embed="Rfa54afa5736d495e"/>
           <a:stretch xmlns:a="http://schemas.openxmlformats.org/drawingml/2006/main">
             <a:fillRect l="0" t="0" r="0" b="0"/>
           </a:stretch>
@@ -5916,10 +5916,10 @@
           <p:nvPr/>
         </p:nvPicPr>
         <p:blipFill>
-          <a:blip xmlns:r="http://schemas.openxmlformats.org/officeDocument/2006/relationships" xmlns:a="http://schemas.openxmlformats.org/drawingml/2006/main" r:embed="R029888e8b2c4464b">
+          <a:blip xmlns:r="http://schemas.openxmlformats.org/officeDocument/2006/relationships" xmlns:a="http://schemas.openxmlformats.org/drawingml/2006/main" r:embed="Rfa54afa5736d495e">
             <a:extLst>
               <a:ext uri="{96DAC541-7B7A-43D3-8B79-37D633B846F1}">
-                <asvg:svgBlip xmlns:asvg="http://schemas.microsoft.com/office/drawing/2016/SVG/main" r:embed="R45585de07f28434e"/>
+                <asvg:svgBlip xmlns:asvg="http://schemas.microsoft.com/office/drawing/2016/SVG/main" r:embed="R0b49b70fcde14465"/>
               </a:ext>
             </a:extLst>
           </a:blip>
@@ -5946,10 +5946,10 @@
           <p:nvPr/>
         </p:nvPicPr>
         <p:blipFill>
-          <a:blip xmlns:r="http://schemas.openxmlformats.org/officeDocument/2006/relationships" xmlns:a="http://schemas.openxmlformats.org/drawingml/2006/main" r:embed="R23113d6efe744746">
+          <a:blip xmlns:r="http://schemas.openxmlformats.org/officeDocument/2006/relationships" xmlns:a="http://schemas.openxmlformats.org/drawingml/2006/main" r:embed="R9038f0039e3f4846">
             <a:extLst>
               <a:ext uri="{96DAC541-7B7A-43D3-8B79-37D633B846F1}">
-                <asvg:svgBlip xmlns:asvg="http://schemas.microsoft.com/office/drawing/2016/SVG/main" r:embed="Rf3598c2fc0824c9b"/>
+                <asvg:svgBlip xmlns:asvg="http://schemas.microsoft.com/office/drawing/2016/SVG/main" r:embed="R78ef2d87ec0f4ef5"/>
               </a:ext>
             </a:extLst>
           </a:blip>
@@ -5976,7 +5976,7 @@
           <p:nvPr/>
         </p:nvPicPr>
         <p:blipFill>
-          <a:blip xmlns:r="http://schemas.openxmlformats.org/officeDocument/2006/relationships" xmlns:a="http://schemas.openxmlformats.org/drawingml/2006/main" r:embed="Rdafc28eb2bfc4e4f"/>
+          <a:blip xmlns:r="http://schemas.openxmlformats.org/officeDocument/2006/relationships" xmlns:a="http://schemas.openxmlformats.org/drawingml/2006/main" r:embed="R6dc4e79d999f48c6"/>
           <a:stretch xmlns:a="http://schemas.openxmlformats.org/drawingml/2006/main">
             <a:fillRect l="0" t="0" r="0" b="0"/>
           </a:stretch>
@@ -6000,10 +6000,10 @@
           <p:nvPr/>
         </p:nvPicPr>
         <p:blipFill>
-          <a:blip xmlns:r="http://schemas.openxmlformats.org/officeDocument/2006/relationships" xmlns:a="http://schemas.openxmlformats.org/drawingml/2006/main" r:embed="R233baec7b7d74fff">
+          <a:blip xmlns:r="http://schemas.openxmlformats.org/officeDocument/2006/relationships" xmlns:a="http://schemas.openxmlformats.org/drawingml/2006/main" r:embed="R454bb4f4e7264980">
             <a:extLst>
               <a:ext uri="{96DAC541-7B7A-43D3-8B79-37D633B846F1}">
-                <asvg:svgBlip xmlns:asvg="http://schemas.microsoft.com/office/drawing/2016/SVG/main" r:embed="Ra513353172c940b9"/>
+                <asvg:svgBlip xmlns:asvg="http://schemas.microsoft.com/office/drawing/2016/SVG/main" r:embed="Re121eb99acad4eda"/>
               </a:ext>
             </a:extLst>
           </a:blip>
@@ -6030,10 +6030,10 @@
           <p:nvPr/>
         </p:nvPicPr>
         <p:blipFill>
-          <a:blip xmlns:r="http://schemas.openxmlformats.org/officeDocument/2006/relationships" xmlns:a="http://schemas.openxmlformats.org/drawingml/2006/main" r:embed="R4ad23e12343449c1">
+          <a:blip xmlns:r="http://schemas.openxmlformats.org/officeDocument/2006/relationships" xmlns:a="http://schemas.openxmlformats.org/drawingml/2006/main" r:embed="R6dc4e79d999f48c6">
             <a:extLst>
               <a:ext uri="{96DAC541-7B7A-43D3-8B79-37D633B846F1}">
-                <asvg:svgBlip xmlns:asvg="http://schemas.microsoft.com/office/drawing/2016/SVG/main" r:embed="Rdfb05178c68d44ef"/>
+                <asvg:svgBlip xmlns:asvg="http://schemas.microsoft.com/office/drawing/2016/SVG/main" r:embed="Rea1255976e6945f8"/>
               </a:ext>
             </a:extLst>
           </a:blip>
@@ -6060,7 +6060,7 @@
           <p:nvPr/>
         </p:nvPicPr>
         <p:blipFill>
-          <a:blip xmlns:r="http://schemas.openxmlformats.org/officeDocument/2006/relationships" xmlns:a="http://schemas.openxmlformats.org/drawingml/2006/main" r:embed="Re5d95ea2943a4791"/>
+          <a:blip xmlns:r="http://schemas.openxmlformats.org/officeDocument/2006/relationships" xmlns:a="http://schemas.openxmlformats.org/drawingml/2006/main" r:embed="Rae2f87206a7d46cb"/>
           <a:stretch xmlns:a="http://schemas.openxmlformats.org/drawingml/2006/main">
             <a:fillRect l="0" t="0" r="0" b="0"/>
           </a:stretch>
@@ -6653,10 +6653,10 @@
           <p:nvPr/>
         </p:nvPicPr>
         <p:blipFill>
-          <a:blip xmlns:r="http://schemas.openxmlformats.org/officeDocument/2006/relationships" xmlns:a="http://schemas.openxmlformats.org/drawingml/2006/main" r:embed="R2b72f2bd09d84787">
+          <a:blip xmlns:r="http://schemas.openxmlformats.org/officeDocument/2006/relationships" xmlns:a="http://schemas.openxmlformats.org/drawingml/2006/main" r:embed="R88405c5e0d714086">
             <a:extLst>
               <a:ext uri="{96DAC541-7B7A-43D3-8B79-37D633B846F1}">
-                <asvg:svgBlip xmlns:asvg="http://schemas.microsoft.com/office/drawing/2016/SVG/main" r:embed="Rb8993d4190bd4aeb"/>
+                <asvg:svgBlip xmlns:asvg="http://schemas.microsoft.com/office/drawing/2016/SVG/main" r:embed="R5384ab69ecde4aa4"/>
               </a:ext>
             </a:extLst>
           </a:blip>
@@ -7097,10 +7097,10 @@
           <p:nvPr/>
         </p:nvPicPr>
         <p:blipFill>
-          <a:blip xmlns:r="http://schemas.openxmlformats.org/officeDocument/2006/relationships" xmlns:a="http://schemas.openxmlformats.org/drawingml/2006/main" r:embed="Re86f429534764ed6">
+          <a:blip xmlns:r="http://schemas.openxmlformats.org/officeDocument/2006/relationships" xmlns:a="http://schemas.openxmlformats.org/drawingml/2006/main" r:embed="Ra9f5b87651844d9e">
             <a:extLst>
               <a:ext uri="{96DAC541-7B7A-43D3-8B79-37D633B846F1}">
-                <asvg:svgBlip xmlns:asvg="http://schemas.microsoft.com/office/drawing/2016/SVG/main" r:embed="Rf6201aad91614fb6"/>
+                <asvg:svgBlip xmlns:asvg="http://schemas.microsoft.com/office/drawing/2016/SVG/main" r:embed="R825de3799b1142c9"/>
               </a:ext>
             </a:extLst>
           </a:blip>
@@ -7127,10 +7127,10 @@
           <p:nvPr/>
         </p:nvPicPr>
         <p:blipFill>
-          <a:blip xmlns:r="http://schemas.openxmlformats.org/officeDocument/2006/relationships" xmlns:a="http://schemas.openxmlformats.org/drawingml/2006/main" r:embed="Rba4dba115d0341f9">
+          <a:blip xmlns:r="http://schemas.openxmlformats.org/officeDocument/2006/relationships" xmlns:a="http://schemas.openxmlformats.org/drawingml/2006/main" r:embed="R83d0dfb472c843ce">
             <a:extLst>
               <a:ext uri="{96DAC541-7B7A-43D3-8B79-37D633B846F1}">
-                <asvg:svgBlip xmlns:asvg="http://schemas.microsoft.com/office/drawing/2016/SVG/main" r:embed="Re90f1b8c43dd438e"/>
+                <asvg:svgBlip xmlns:asvg="http://schemas.microsoft.com/office/drawing/2016/SVG/main" r:embed="R21de9328ab304fcf"/>
               </a:ext>
             </a:extLst>
           </a:blip>
@@ -7157,10 +7157,10 @@
           <p:nvPr/>
         </p:nvPicPr>
         <p:blipFill>
-          <a:blip xmlns:r="http://schemas.openxmlformats.org/officeDocument/2006/relationships" xmlns:a="http://schemas.openxmlformats.org/drawingml/2006/main" r:embed="R899eefd9f7684d38">
+          <a:blip xmlns:r="http://schemas.openxmlformats.org/officeDocument/2006/relationships" xmlns:a="http://schemas.openxmlformats.org/drawingml/2006/main" r:embed="R35d2fab0d0744e62">
             <a:extLst>
               <a:ext uri="{96DAC541-7B7A-43D3-8B79-37D633B846F1}">
-                <asvg:svgBlip xmlns:asvg="http://schemas.microsoft.com/office/drawing/2016/SVG/main" r:embed="Rf44288c86733497d"/>
+                <asvg:svgBlip xmlns:asvg="http://schemas.microsoft.com/office/drawing/2016/SVG/main" r:embed="R59a9c0617c3f47d2"/>
               </a:ext>
             </a:extLst>
           </a:blip>
@@ -7187,7 +7187,7 @@
           <p:nvPr/>
         </p:nvPicPr>
         <p:blipFill>
-          <a:blip xmlns:r="http://schemas.openxmlformats.org/officeDocument/2006/relationships" xmlns:a="http://schemas.openxmlformats.org/drawingml/2006/main" r:embed="Reac6abdf59564899"/>
+          <a:blip xmlns:r="http://schemas.openxmlformats.org/officeDocument/2006/relationships" xmlns:a="http://schemas.openxmlformats.org/drawingml/2006/main" r:embed="R4543ed8f06aa4760"/>
           <a:stretch xmlns:a="http://schemas.openxmlformats.org/drawingml/2006/main">
             <a:fillRect l="0" t="0" r="0" b="0"/>
           </a:stretch>
@@ -7211,10 +7211,10 @@
           <p:nvPr/>
         </p:nvPicPr>
         <p:blipFill>
-          <a:blip xmlns:r="http://schemas.openxmlformats.org/officeDocument/2006/relationships" xmlns:a="http://schemas.openxmlformats.org/drawingml/2006/main" r:embed="R251032d1474846da">
+          <a:blip xmlns:r="http://schemas.openxmlformats.org/officeDocument/2006/relationships" xmlns:a="http://schemas.openxmlformats.org/drawingml/2006/main" r:embed="R84b13dcc068b45b7">
             <a:extLst>
               <a:ext uri="{96DAC541-7B7A-43D3-8B79-37D633B846F1}">
-                <asvg:svgBlip xmlns:asvg="http://schemas.microsoft.com/office/drawing/2016/SVG/main" r:embed="R2d7555f615964e61"/>
+                <asvg:svgBlip xmlns:asvg="http://schemas.microsoft.com/office/drawing/2016/SVG/main" r:embed="R5035eaaf233e4e09"/>
               </a:ext>
             </a:extLst>
           </a:blip>
@@ -7241,10 +7241,10 @@
           <p:nvPr/>
         </p:nvPicPr>
         <p:blipFill>
-          <a:blip xmlns:r="http://schemas.openxmlformats.org/officeDocument/2006/relationships" xmlns:a="http://schemas.openxmlformats.org/drawingml/2006/main" r:embed="R535c7e6997614080">
+          <a:blip xmlns:r="http://schemas.openxmlformats.org/officeDocument/2006/relationships" xmlns:a="http://schemas.openxmlformats.org/drawingml/2006/main" r:embed="R4543ed8f06aa4760">
             <a:extLst>
               <a:ext uri="{96DAC541-7B7A-43D3-8B79-37D633B846F1}">
-                <asvg:svgBlip xmlns:asvg="http://schemas.microsoft.com/office/drawing/2016/SVG/main" r:embed="R1c63044ec8af4ff7"/>
+                <asvg:svgBlip xmlns:asvg="http://schemas.microsoft.com/office/drawing/2016/SVG/main" r:embed="Ra69f67493a9c42a2"/>
               </a:ext>
             </a:extLst>
           </a:blip>
@@ -7271,7 +7271,7 @@
           <p:nvPr/>
         </p:nvPicPr>
         <p:blipFill>
-          <a:blip xmlns:r="http://schemas.openxmlformats.org/officeDocument/2006/relationships" xmlns:a="http://schemas.openxmlformats.org/drawingml/2006/main" r:embed="R4e27e99777c84d3b"/>
+          <a:blip xmlns:r="http://schemas.openxmlformats.org/officeDocument/2006/relationships" xmlns:a="http://schemas.openxmlformats.org/drawingml/2006/main" r:embed="Rf6529a75db544e3d"/>
           <a:stretch xmlns:a="http://schemas.openxmlformats.org/drawingml/2006/main">
             <a:fillRect l="0" t="0" r="0" b="0"/>
           </a:stretch>
@@ -7295,10 +7295,10 @@
           <p:nvPr/>
         </p:nvPicPr>
         <p:blipFill>
-          <a:blip xmlns:r="http://schemas.openxmlformats.org/officeDocument/2006/relationships" xmlns:a="http://schemas.openxmlformats.org/drawingml/2006/main" r:embed="Rc9638ee44e8046d0">
+          <a:blip xmlns:r="http://schemas.openxmlformats.org/officeDocument/2006/relationships" xmlns:a="http://schemas.openxmlformats.org/drawingml/2006/main" r:embed="R5c5ed75ebc434100">
             <a:extLst>
               <a:ext uri="{96DAC541-7B7A-43D3-8B79-37D633B846F1}">
-                <asvg:svgBlip xmlns:asvg="http://schemas.microsoft.com/office/drawing/2016/SVG/main" r:embed="R61ed32d104af4bab"/>
+                <asvg:svgBlip xmlns:asvg="http://schemas.microsoft.com/office/drawing/2016/SVG/main" r:embed="R4619d21115c34bc1"/>
               </a:ext>
             </a:extLst>
           </a:blip>
@@ -7325,10 +7325,10 @@
           <p:nvPr/>
         </p:nvPicPr>
         <p:blipFill>
-          <a:blip xmlns:r="http://schemas.openxmlformats.org/officeDocument/2006/relationships" xmlns:a="http://schemas.openxmlformats.org/drawingml/2006/main" r:embed="R3343dc9ad4064294">
+          <a:blip xmlns:r="http://schemas.openxmlformats.org/officeDocument/2006/relationships" xmlns:a="http://schemas.openxmlformats.org/drawingml/2006/main" r:embed="Rf6529a75db544e3d">
             <a:extLst>
               <a:ext uri="{96DAC541-7B7A-43D3-8B79-37D633B846F1}">
-                <asvg:svgBlip xmlns:asvg="http://schemas.microsoft.com/office/drawing/2016/SVG/main" r:embed="R99cb8bf06c27420a"/>
+                <asvg:svgBlip xmlns:asvg="http://schemas.microsoft.com/office/drawing/2016/SVG/main" r:embed="R179c9b377f394b37"/>
               </a:ext>
             </a:extLst>
           </a:blip>
@@ -7355,7 +7355,7 @@
           <p:nvPr/>
         </p:nvPicPr>
         <p:blipFill>
-          <a:blip xmlns:r="http://schemas.openxmlformats.org/officeDocument/2006/relationships" xmlns:a="http://schemas.openxmlformats.org/drawingml/2006/main" r:embed="R9d4c7ca5da32404f"/>
+          <a:blip xmlns:r="http://schemas.openxmlformats.org/officeDocument/2006/relationships" xmlns:a="http://schemas.openxmlformats.org/drawingml/2006/main" r:embed="Rc80d257a5c194425"/>
           <a:stretch xmlns:a="http://schemas.openxmlformats.org/drawingml/2006/main">
             <a:fillRect l="0" t="0" r="0" b="0"/>
           </a:stretch>
@@ -7379,10 +7379,10 @@
           <p:nvPr/>
         </p:nvPicPr>
         <p:blipFill>
-          <a:blip xmlns:r="http://schemas.openxmlformats.org/officeDocument/2006/relationships" xmlns:a="http://schemas.openxmlformats.org/drawingml/2006/main" r:embed="Rc35f3821644e4eea">
+          <a:blip xmlns:r="http://schemas.openxmlformats.org/officeDocument/2006/relationships" xmlns:a="http://schemas.openxmlformats.org/drawingml/2006/main" r:embed="R4bb295fd4fc64c51">
             <a:extLst>
               <a:ext uri="{96DAC541-7B7A-43D3-8B79-37D633B846F1}">
-                <asvg:svgBlip xmlns:asvg="http://schemas.microsoft.com/office/drawing/2016/SVG/main" r:embed="R79e097a1403144fe"/>
+                <asvg:svgBlip xmlns:asvg="http://schemas.microsoft.com/office/drawing/2016/SVG/main" r:embed="R5a90792f912a412f"/>
               </a:ext>
             </a:extLst>
           </a:blip>
@@ -7409,10 +7409,10 @@
           <p:nvPr/>
         </p:nvPicPr>
         <p:blipFill>
-          <a:blip xmlns:r="http://schemas.openxmlformats.org/officeDocument/2006/relationships" xmlns:a="http://schemas.openxmlformats.org/drawingml/2006/main" r:embed="Reac6abdf59564899">
+          <a:blip xmlns:r="http://schemas.openxmlformats.org/officeDocument/2006/relationships" xmlns:a="http://schemas.openxmlformats.org/drawingml/2006/main" r:embed="R84ab038c92274bf1">
             <a:extLst>
               <a:ext uri="{96DAC541-7B7A-43D3-8B79-37D633B846F1}">
-                <asvg:svgBlip xmlns:asvg="http://schemas.microsoft.com/office/drawing/2016/SVG/main" r:embed="Ra4d9af28c3fa4309"/>
+                <asvg:svgBlip xmlns:asvg="http://schemas.microsoft.com/office/drawing/2016/SVG/main" r:embed="Rc2da7c030ea7487f"/>
               </a:ext>
             </a:extLst>
           </a:blip>
@@ -7439,7 +7439,7 @@
           <p:nvPr/>
         </p:nvPicPr>
         <p:blipFill>
-          <a:blip xmlns:r="http://schemas.openxmlformats.org/officeDocument/2006/relationships" xmlns:a="http://schemas.openxmlformats.org/drawingml/2006/main" r:embed="Ra920cd21d1d24c23"/>
+          <a:blip xmlns:r="http://schemas.openxmlformats.org/officeDocument/2006/relationships" xmlns:a="http://schemas.openxmlformats.org/drawingml/2006/main" r:embed="Rc31fe3a84a394159"/>
           <a:stretch xmlns:a="http://schemas.openxmlformats.org/drawingml/2006/main">
             <a:fillRect l="0" t="0" r="0" b="0"/>
           </a:stretch>
@@ -7463,10 +7463,10 @@
           <p:nvPr/>
         </p:nvPicPr>
         <p:blipFill>
-          <a:blip xmlns:r="http://schemas.openxmlformats.org/officeDocument/2006/relationships" xmlns:a="http://schemas.openxmlformats.org/drawingml/2006/main" r:embed="R9ea7baecdee94602">
+          <a:blip xmlns:r="http://schemas.openxmlformats.org/officeDocument/2006/relationships" xmlns:a="http://schemas.openxmlformats.org/drawingml/2006/main" r:embed="Rc80d257a5c194425">
             <a:extLst>
               <a:ext uri="{96DAC541-7B7A-43D3-8B79-37D633B846F1}">
-                <asvg:svgBlip xmlns:asvg="http://schemas.microsoft.com/office/drawing/2016/SVG/main" r:embed="Rff224b31c23f4660"/>
+                <asvg:svgBlip xmlns:asvg="http://schemas.microsoft.com/office/drawing/2016/SVG/main" r:embed="R008f62c817fa42d5"/>
               </a:ext>
             </a:extLst>
           </a:blip>
@@ -7493,10 +7493,10 @@
           <p:nvPr/>
         </p:nvPicPr>
         <p:blipFill>
-          <a:blip xmlns:r="http://schemas.openxmlformats.org/officeDocument/2006/relationships" xmlns:a="http://schemas.openxmlformats.org/drawingml/2006/main" r:embed="Rcff4ade7c16f4ea4">
+          <a:blip xmlns:r="http://schemas.openxmlformats.org/officeDocument/2006/relationships" xmlns:a="http://schemas.openxmlformats.org/drawingml/2006/main" r:embed="Rc24f8a7c2e7f4ebb">
             <a:extLst>
               <a:ext uri="{96DAC541-7B7A-43D3-8B79-37D633B846F1}">
-                <asvg:svgBlip xmlns:asvg="http://schemas.microsoft.com/office/drawing/2016/SVG/main" r:embed="Refc50fb042564125"/>
+                <asvg:svgBlip xmlns:asvg="http://schemas.microsoft.com/office/drawing/2016/SVG/main" r:embed="R45ef126349e24ddc"/>
               </a:ext>
             </a:extLst>
           </a:blip>
@@ -7523,7 +7523,7 @@
           <p:nvPr/>
         </p:nvPicPr>
         <p:blipFill>
-          <a:blip xmlns:r="http://schemas.openxmlformats.org/officeDocument/2006/relationships" xmlns:a="http://schemas.openxmlformats.org/drawingml/2006/main" r:embed="R62bbebf4e7634916"/>
+          <a:blip xmlns:r="http://schemas.openxmlformats.org/officeDocument/2006/relationships" xmlns:a="http://schemas.openxmlformats.org/drawingml/2006/main" r:embed="R2974fd890dc145cd"/>
           <a:stretch xmlns:a="http://schemas.openxmlformats.org/drawingml/2006/main">
             <a:fillRect l="0" t="0" r="0" b="0"/>
           </a:stretch>
@@ -7547,10 +7547,10 @@
           <p:nvPr/>
         </p:nvPicPr>
         <p:blipFill>
-          <a:blip xmlns:r="http://schemas.openxmlformats.org/officeDocument/2006/relationships" xmlns:a="http://schemas.openxmlformats.org/drawingml/2006/main" r:embed="R4e27e99777c84d3b">
+          <a:blip xmlns:r="http://schemas.openxmlformats.org/officeDocument/2006/relationships" xmlns:a="http://schemas.openxmlformats.org/drawingml/2006/main" r:embed="Rc31fe3a84a394159">
             <a:extLst>
               <a:ext uri="{96DAC541-7B7A-43D3-8B79-37D633B846F1}">
-                <asvg:svgBlip xmlns:asvg="http://schemas.microsoft.com/office/drawing/2016/SVG/main" r:embed="Ra079f27914284d6c"/>
+                <asvg:svgBlip xmlns:asvg="http://schemas.microsoft.com/office/drawing/2016/SVG/main" r:embed="R02d747742ec349ad"/>
               </a:ext>
             </a:extLst>
           </a:blip>
@@ -7577,10 +7577,10 @@
           <p:nvPr/>
         </p:nvPicPr>
         <p:blipFill>
-          <a:blip xmlns:r="http://schemas.openxmlformats.org/officeDocument/2006/relationships" xmlns:a="http://schemas.openxmlformats.org/drawingml/2006/main" r:embed="Rd722721dd2304eac">
+          <a:blip xmlns:r="http://schemas.openxmlformats.org/officeDocument/2006/relationships" xmlns:a="http://schemas.openxmlformats.org/drawingml/2006/main" r:embed="R8dba393d99524276">
             <a:extLst>
               <a:ext uri="{96DAC541-7B7A-43D3-8B79-37D633B846F1}">
-                <asvg:svgBlip xmlns:asvg="http://schemas.microsoft.com/office/drawing/2016/SVG/main" r:embed="R10ba4669045a49f6"/>
+                <asvg:svgBlip xmlns:asvg="http://schemas.microsoft.com/office/drawing/2016/SVG/main" r:embed="R4f41e3a6caa1442a"/>
               </a:ext>
             </a:extLst>
           </a:blip>
@@ -7607,7 +7607,7 @@
           <p:nvPr/>
         </p:nvPicPr>
         <p:blipFill>
-          <a:blip xmlns:r="http://schemas.openxmlformats.org/officeDocument/2006/relationships" xmlns:a="http://schemas.openxmlformats.org/drawingml/2006/main" r:embed="R86c544278ab24d48"/>
+          <a:blip xmlns:r="http://schemas.openxmlformats.org/officeDocument/2006/relationships" xmlns:a="http://schemas.openxmlformats.org/drawingml/2006/main" r:embed="Rcba23fe5173b4d87"/>
           <a:stretch xmlns:a="http://schemas.openxmlformats.org/drawingml/2006/main">
             <a:fillRect l="0" t="0" r="0" b="0"/>
           </a:stretch>
@@ -7631,10 +7631,10 @@
           <p:nvPr/>
         </p:nvPicPr>
         <p:blipFill>
-          <a:blip xmlns:r="http://schemas.openxmlformats.org/officeDocument/2006/relationships" xmlns:a="http://schemas.openxmlformats.org/drawingml/2006/main" r:embed="Ra521018246324327">
+          <a:blip xmlns:r="http://schemas.openxmlformats.org/officeDocument/2006/relationships" xmlns:a="http://schemas.openxmlformats.org/drawingml/2006/main" r:embed="R3e7b4fa02dca489d">
             <a:extLst>
               <a:ext uri="{96DAC541-7B7A-43D3-8B79-37D633B846F1}">
-                <asvg:svgBlip xmlns:asvg="http://schemas.microsoft.com/office/drawing/2016/SVG/main" r:embed="Rf8d9465742c94c4e"/>
+                <asvg:svgBlip xmlns:asvg="http://schemas.microsoft.com/office/drawing/2016/SVG/main" r:embed="R020d8f2a705241b1"/>
               </a:ext>
             </a:extLst>
           </a:blip>
@@ -8225,10 +8225,10 @@
           <p:nvPr/>
         </p:nvPicPr>
         <p:blipFill>
-          <a:blip xmlns:r="http://schemas.openxmlformats.org/officeDocument/2006/relationships" xmlns:a="http://schemas.openxmlformats.org/drawingml/2006/main" r:embed="R9d4c7ca5da32404f">
+          <a:blip xmlns:r="http://schemas.openxmlformats.org/officeDocument/2006/relationships" xmlns:a="http://schemas.openxmlformats.org/drawingml/2006/main" r:embed="R2974fd890dc145cd">
             <a:extLst>
               <a:ext uri="{96DAC541-7B7A-43D3-8B79-37D633B846F1}">
-                <asvg:svgBlip xmlns:asvg="http://schemas.microsoft.com/office/drawing/2016/SVG/main" r:embed="R137d1f50d58a4964"/>
+                <asvg:svgBlip xmlns:asvg="http://schemas.microsoft.com/office/drawing/2016/SVG/main" r:embed="R36950840c2664f19"/>
               </a:ext>
             </a:extLst>
           </a:blip>
@@ -9491,10 +9491,10 @@
           <p:nvPr/>
         </p:nvPicPr>
         <p:blipFill>
-          <a:blip xmlns:r="http://schemas.openxmlformats.org/officeDocument/2006/relationships" xmlns:a="http://schemas.openxmlformats.org/drawingml/2006/main" r:embed="R752e43fd68d74e1f">
+          <a:blip xmlns:r="http://schemas.openxmlformats.org/officeDocument/2006/relationships" xmlns:a="http://schemas.openxmlformats.org/drawingml/2006/main" r:embed="R567ea27bedf34963">
             <a:extLst>
               <a:ext uri="{96DAC541-7B7A-43D3-8B79-37D633B846F1}">
-                <asvg:svgBlip xmlns:asvg="http://schemas.microsoft.com/office/drawing/2016/SVG/main" r:embed="R06fbc0f26d6149cd"/>
+                <asvg:svgBlip xmlns:asvg="http://schemas.microsoft.com/office/drawing/2016/SVG/main" r:embed="Raaae2a2e1bc14cd3"/>
               </a:ext>
             </a:extLst>
           </a:blip>
@@ -9793,10 +9793,10 @@
           <p:nvPr/>
         </p:nvPicPr>
         <p:blipFill>
-          <a:blip xmlns:r="http://schemas.openxmlformats.org/officeDocument/2006/relationships" xmlns:a="http://schemas.openxmlformats.org/drawingml/2006/main" r:embed="Rcdce15c8c2c44b2f">
+          <a:blip xmlns:r="http://schemas.openxmlformats.org/officeDocument/2006/relationships" xmlns:a="http://schemas.openxmlformats.org/drawingml/2006/main" r:embed="Re71d4d78600641ee">
             <a:extLst>
               <a:ext uri="{96DAC541-7B7A-43D3-8B79-37D633B846F1}">
-                <asvg:svgBlip xmlns:asvg="http://schemas.microsoft.com/office/drawing/2016/SVG/main" r:embed="Rbe9e06c034394eb3"/>
+                <asvg:svgBlip xmlns:asvg="http://schemas.microsoft.com/office/drawing/2016/SVG/main" r:embed="Rf86b926443174e8b"/>
               </a:ext>
             </a:extLst>
           </a:blip>
@@ -10443,10 +10443,10 @@
           <p:nvPr/>
         </p:nvPicPr>
         <p:blipFill>
-          <a:blip xmlns:r="http://schemas.openxmlformats.org/officeDocument/2006/relationships" xmlns:a="http://schemas.openxmlformats.org/drawingml/2006/main" r:embed="Rc488417adf74415c">
+          <a:blip xmlns:r="http://schemas.openxmlformats.org/officeDocument/2006/relationships" xmlns:a="http://schemas.openxmlformats.org/drawingml/2006/main" r:embed="Rf0fbe18b49e34935">
             <a:extLst>
               <a:ext uri="{96DAC541-7B7A-43D3-8B79-37D633B846F1}">
-                <asvg:svgBlip xmlns:asvg="http://schemas.microsoft.com/office/drawing/2016/SVG/main" r:embed="R2d296043f1194d90"/>
+                <asvg:svgBlip xmlns:asvg="http://schemas.microsoft.com/office/drawing/2016/SVG/main" r:embed="R0961378df6984746"/>
               </a:ext>
             </a:extLst>
           </a:blip>
@@ -10498,10 +10498,10 @@
           <p:nvPr/>
         </p:nvPicPr>
         <p:blipFill>
-          <a:blip xmlns:r="http://schemas.openxmlformats.org/officeDocument/2006/relationships" xmlns:a="http://schemas.openxmlformats.org/drawingml/2006/main" r:embed="R08ec96dd568a4133">
+          <a:blip xmlns:r="http://schemas.openxmlformats.org/officeDocument/2006/relationships" xmlns:a="http://schemas.openxmlformats.org/drawingml/2006/main" r:embed="Raec63d91cb244f93">
             <a:extLst>
               <a:ext uri="{96DAC541-7B7A-43D3-8B79-37D633B846F1}">
-                <asvg:svgBlip xmlns:asvg="http://schemas.microsoft.com/office/drawing/2016/SVG/main" r:embed="R9afabf99418e482a"/>
+                <asvg:svgBlip xmlns:asvg="http://schemas.microsoft.com/office/drawing/2016/SVG/main" r:embed="R9ad2a93ac6f0405f"/>
               </a:ext>
             </a:extLst>
           </a:blip>
@@ -10652,10 +10652,10 @@
           <p:nvPr/>
         </p:nvPicPr>
         <p:blipFill>
-          <a:blip xmlns:r="http://schemas.openxmlformats.org/officeDocument/2006/relationships" xmlns:a="http://schemas.openxmlformats.org/drawingml/2006/main" r:embed="Ra01c1151b9704192">
+          <a:blip xmlns:r="http://schemas.openxmlformats.org/officeDocument/2006/relationships" xmlns:a="http://schemas.openxmlformats.org/drawingml/2006/main" r:embed="R7e5b52513e694161">
             <a:extLst>
               <a:ext uri="{96DAC541-7B7A-43D3-8B79-37D633B846F1}">
-                <asvg:svgBlip xmlns:asvg="http://schemas.microsoft.com/office/drawing/2016/SVG/main" r:embed="R86997ee25733423c"/>
+                <asvg:svgBlip xmlns:asvg="http://schemas.microsoft.com/office/drawing/2016/SVG/main" r:embed="Rc0d0db6bfc8b4a5c"/>
               </a:ext>
             </a:extLst>
           </a:blip>
@@ -10806,10 +10806,10 @@
           <p:nvPr/>
         </p:nvPicPr>
         <p:blipFill>
-          <a:blip xmlns:r="http://schemas.openxmlformats.org/officeDocument/2006/relationships" xmlns:a="http://schemas.openxmlformats.org/drawingml/2006/main" r:embed="R480fc39373044b4b">
+          <a:blip xmlns:r="http://schemas.openxmlformats.org/officeDocument/2006/relationships" xmlns:a="http://schemas.openxmlformats.org/drawingml/2006/main" r:embed="Rfa14cf715ef14b75">
             <a:extLst>
               <a:ext uri="{96DAC541-7B7A-43D3-8B79-37D633B846F1}">
-                <asvg:svgBlip xmlns:asvg="http://schemas.microsoft.com/office/drawing/2016/SVG/main" r:embed="Rb3c4a0e8830b484c"/>
+                <asvg:svgBlip xmlns:asvg="http://schemas.microsoft.com/office/drawing/2016/SVG/main" r:embed="R532f7f64c9d448d1"/>
               </a:ext>
             </a:extLst>
           </a:blip>
@@ -11374,10 +11374,10 @@
           <p:nvPr/>
         </p:nvPicPr>
         <p:blipFill>
-          <a:blip xmlns:r="http://schemas.openxmlformats.org/officeDocument/2006/relationships" xmlns:a="http://schemas.openxmlformats.org/drawingml/2006/main" r:embed="R416661c724364aca">
+          <a:blip xmlns:r="http://schemas.openxmlformats.org/officeDocument/2006/relationships" xmlns:a="http://schemas.openxmlformats.org/drawingml/2006/main" r:embed="Rad327d5341bb484c">
             <a:extLst>
               <a:ext uri="{96DAC541-7B7A-43D3-8B79-37D633B846F1}">
-                <asvg:svgBlip xmlns:asvg="http://schemas.microsoft.com/office/drawing/2016/SVG/main" r:embed="R9fa3811b5ba04ee3"/>
+                <asvg:svgBlip xmlns:asvg="http://schemas.microsoft.com/office/drawing/2016/SVG/main" r:embed="Rdbfc9562175a44af"/>
               </a:ext>
             </a:extLst>
           </a:blip>
@@ -11429,10 +11429,10 @@
           <p:nvPr/>
         </p:nvPicPr>
         <p:blipFill>
-          <a:blip xmlns:r="http://schemas.openxmlformats.org/officeDocument/2006/relationships" xmlns:a="http://schemas.openxmlformats.org/drawingml/2006/main" r:embed="Rc4fbb6deb5df46d6">
+          <a:blip xmlns:r="http://schemas.openxmlformats.org/officeDocument/2006/relationships" xmlns:a="http://schemas.openxmlformats.org/drawingml/2006/main" r:embed="R7ac969da91cc41b2">
             <a:extLst>
               <a:ext uri="{96DAC541-7B7A-43D3-8B79-37D633B846F1}">
-                <asvg:svgBlip xmlns:asvg="http://schemas.microsoft.com/office/drawing/2016/SVG/main" r:embed="R4bdcddd4306b4562"/>
+                <asvg:svgBlip xmlns:asvg="http://schemas.microsoft.com/office/drawing/2016/SVG/main" r:embed="R918b52d5b4c04d2e"/>
               </a:ext>
             </a:extLst>
           </a:blip>
@@ -11635,10 +11635,10 @@
           <p:nvPr/>
         </p:nvPicPr>
         <p:blipFill>
-          <a:blip xmlns:r="http://schemas.openxmlformats.org/officeDocument/2006/relationships" xmlns:a="http://schemas.openxmlformats.org/drawingml/2006/main" r:embed="R1a7c173e065b46c7">
+          <a:blip xmlns:r="http://schemas.openxmlformats.org/officeDocument/2006/relationships" xmlns:a="http://schemas.openxmlformats.org/drawingml/2006/main" r:embed="Rc121d1de35c04250">
             <a:extLst>
               <a:ext uri="{96DAC541-7B7A-43D3-8B79-37D633B846F1}">
-                <asvg:svgBlip xmlns:asvg="http://schemas.microsoft.com/office/drawing/2016/SVG/main" r:embed="R0cf0a67f27ee4a10"/>
+                <asvg:svgBlip xmlns:asvg="http://schemas.microsoft.com/office/drawing/2016/SVG/main" r:embed="R810b02ae31c9412e"/>
               </a:ext>
             </a:extLst>
           </a:blip>
@@ -11837,10 +11837,10 @@
           <p:nvPr/>
         </p:nvPicPr>
         <p:blipFill>
-          <a:blip xmlns:r="http://schemas.openxmlformats.org/officeDocument/2006/relationships" xmlns:a="http://schemas.openxmlformats.org/drawingml/2006/main" r:embed="R6e1aa5c6bc814d07">
+          <a:blip xmlns:r="http://schemas.openxmlformats.org/officeDocument/2006/relationships" xmlns:a="http://schemas.openxmlformats.org/drawingml/2006/main" r:embed="R6eea6056519c48a3">
             <a:extLst>
               <a:ext uri="{96DAC541-7B7A-43D3-8B79-37D633B846F1}">
-                <asvg:svgBlip xmlns:asvg="http://schemas.microsoft.com/office/drawing/2016/SVG/main" r:embed="Rf1c0935fa0614309"/>
+                <asvg:svgBlip xmlns:asvg="http://schemas.microsoft.com/office/drawing/2016/SVG/main" r:embed="R604cbad290d74a9c"/>
               </a:ext>
             </a:extLst>
           </a:blip>
@@ -12043,10 +12043,10 @@
           <p:nvPr/>
         </p:nvPicPr>
         <p:blipFill>
-          <a:blip xmlns:r="http://schemas.openxmlformats.org/officeDocument/2006/relationships" xmlns:a="http://schemas.openxmlformats.org/drawingml/2006/main" r:embed="Re23180a13f464438">
+          <a:blip xmlns:r="http://schemas.openxmlformats.org/officeDocument/2006/relationships" xmlns:a="http://schemas.openxmlformats.org/drawingml/2006/main" r:embed="R52b69a2a1c264bbc">
             <a:extLst>
               <a:ext uri="{96DAC541-7B7A-43D3-8B79-37D633B846F1}">
-                <asvg:svgBlip xmlns:asvg="http://schemas.microsoft.com/office/drawing/2016/SVG/main" r:embed="R82f97fe0c8e94af0"/>
+                <asvg:svgBlip xmlns:asvg="http://schemas.microsoft.com/office/drawing/2016/SVG/main" r:embed="Rf9fda175c45647bd"/>
               </a:ext>
             </a:extLst>
           </a:blip>
@@ -14025,10 +14025,10 @@
           <p:nvPr/>
         </p:nvPicPr>
         <p:blipFill>
-          <a:blip xmlns:r="http://schemas.openxmlformats.org/officeDocument/2006/relationships" xmlns:a="http://schemas.openxmlformats.org/drawingml/2006/main" r:embed="R1cf7f73ac6e54be1">
+          <a:blip xmlns:r="http://schemas.openxmlformats.org/officeDocument/2006/relationships" xmlns:a="http://schemas.openxmlformats.org/drawingml/2006/main" r:embed="R735de9b52f8741e3">
             <a:extLst>
               <a:ext uri="{96DAC541-7B7A-43D3-8B79-37D633B846F1}">
-                <asvg:svgBlip xmlns:asvg="http://schemas.microsoft.com/office/drawing/2016/SVG/main" r:embed="Ra6cee26bdb2642ca"/>
+                <asvg:svgBlip xmlns:asvg="http://schemas.microsoft.com/office/drawing/2016/SVG/main" r:embed="R6cd2d79202b4436f"/>
               </a:ext>
             </a:extLst>
           </a:blip>
@@ -15455,10 +15455,10 @@
           <p:nvPr/>
         </p:nvPicPr>
         <p:blipFill>
-          <a:blip xmlns:r="http://schemas.openxmlformats.org/officeDocument/2006/relationships" xmlns:a="http://schemas.openxmlformats.org/drawingml/2006/main" r:embed="R90f9814a5a2d42ab">
+          <a:blip xmlns:r="http://schemas.openxmlformats.org/officeDocument/2006/relationships" xmlns:a="http://schemas.openxmlformats.org/drawingml/2006/main" r:embed="Rae31f841405943bd">
             <a:extLst>
               <a:ext uri="{96DAC541-7B7A-43D3-8B79-37D633B846F1}">
-                <asvg:svgBlip xmlns:asvg="http://schemas.microsoft.com/office/drawing/2016/SVG/main" r:embed="Redb64e24fafa4fad"/>
+                <asvg:svgBlip xmlns:asvg="http://schemas.microsoft.com/office/drawing/2016/SVG/main" r:embed="R46f78b68fc8b4b8c"/>
               </a:ext>
             </a:extLst>
           </a:blip>
@@ -15612,10 +15612,10 @@
           <p:nvPr/>
         </p:nvPicPr>
         <p:blipFill>
-          <a:blip xmlns:r="http://schemas.openxmlformats.org/officeDocument/2006/relationships" xmlns:a="http://schemas.openxmlformats.org/drawingml/2006/main" r:embed="R90c59c0be9574a0b">
+          <a:blip xmlns:r="http://schemas.openxmlformats.org/officeDocument/2006/relationships" xmlns:a="http://schemas.openxmlformats.org/drawingml/2006/main" r:embed="Ra228e4e6dc01470c">
             <a:extLst>
               <a:ext uri="{96DAC541-7B7A-43D3-8B79-37D633B846F1}">
-                <asvg:svgBlip xmlns:asvg="http://schemas.microsoft.com/office/drawing/2016/SVG/main" r:embed="Rcb5fa7c547a54755"/>
+                <asvg:svgBlip xmlns:asvg="http://schemas.microsoft.com/office/drawing/2016/SVG/main" r:embed="R149d2f3b0a924112"/>
               </a:ext>
             </a:extLst>
           </a:blip>
@@ -15769,10 +15769,10 @@
           <p:nvPr/>
         </p:nvPicPr>
         <p:blipFill>
-          <a:blip xmlns:r="http://schemas.openxmlformats.org/officeDocument/2006/relationships" xmlns:a="http://schemas.openxmlformats.org/drawingml/2006/main" r:embed="Rdd74b3ddd0834751">
+          <a:blip xmlns:r="http://schemas.openxmlformats.org/officeDocument/2006/relationships" xmlns:a="http://schemas.openxmlformats.org/drawingml/2006/main" r:embed="Rafe93fe9b17b43c4">
             <a:extLst>
               <a:ext uri="{96DAC541-7B7A-43D3-8B79-37D633B846F1}">
-                <asvg:svgBlip xmlns:asvg="http://schemas.microsoft.com/office/drawing/2016/SVG/main" r:embed="Ra653c1b819a64471"/>
+                <asvg:svgBlip xmlns:asvg="http://schemas.microsoft.com/office/drawing/2016/SVG/main" r:embed="Rfac7e645139d4620"/>
               </a:ext>
             </a:extLst>
           </a:blip>
@@ -15926,10 +15926,10 @@
           <p:nvPr/>
         </p:nvPicPr>
         <p:blipFill>
-          <a:blip xmlns:r="http://schemas.openxmlformats.org/officeDocument/2006/relationships" xmlns:a="http://schemas.openxmlformats.org/drawingml/2006/main" r:embed="R9f85a238903f489b">
+          <a:blip xmlns:r="http://schemas.openxmlformats.org/officeDocument/2006/relationships" xmlns:a="http://schemas.openxmlformats.org/drawingml/2006/main" r:embed="R38788d09ab294cb1">
             <a:extLst>
               <a:ext uri="{96DAC541-7B7A-43D3-8B79-37D633B846F1}">
-                <asvg:svgBlip xmlns:asvg="http://schemas.microsoft.com/office/drawing/2016/SVG/main" r:embed="Rf8f3418fd5bf4abb"/>
+                <asvg:svgBlip xmlns:asvg="http://schemas.microsoft.com/office/drawing/2016/SVG/main" r:embed="R551fccbd3f534b35"/>
               </a:ext>
             </a:extLst>
           </a:blip>
@@ -16665,10 +16665,10 @@
           <p:nvPr/>
         </p:nvPicPr>
         <p:blipFill>
-          <a:blip xmlns:r="http://schemas.openxmlformats.org/officeDocument/2006/relationships" xmlns:a="http://schemas.openxmlformats.org/drawingml/2006/main" r:embed="R265e91184c054323">
+          <a:blip xmlns:r="http://schemas.openxmlformats.org/officeDocument/2006/relationships" xmlns:a="http://schemas.openxmlformats.org/drawingml/2006/main" r:embed="Rfe997ac9e23a4f3a">
             <a:extLst>
               <a:ext uri="{96DAC541-7B7A-43D3-8B79-37D633B846F1}">
-                <asvg:svgBlip xmlns:asvg="http://schemas.microsoft.com/office/drawing/2016/SVG/main" r:embed="R6fd73fece50a4716"/>
+                <asvg:svgBlip xmlns:asvg="http://schemas.microsoft.com/office/drawing/2016/SVG/main" r:embed="R2e91929434ce42f3"/>
               </a:ext>
             </a:extLst>
           </a:blip>
@@ -17254,10 +17254,10 @@
           <p:nvPr/>
         </p:nvPicPr>
         <p:blipFill>
-          <a:blip xmlns:r="http://schemas.openxmlformats.org/officeDocument/2006/relationships" xmlns:a="http://schemas.openxmlformats.org/drawingml/2006/main" r:embed="R53c50551941f4c69">
+          <a:blip xmlns:r="http://schemas.openxmlformats.org/officeDocument/2006/relationships" xmlns:a="http://schemas.openxmlformats.org/drawingml/2006/main" r:embed="Rc6d48d1101be4c3d">
             <a:extLst>
               <a:ext uri="{96DAC541-7B7A-43D3-8B79-37D633B846F1}">
-                <asvg:svgBlip xmlns:asvg="http://schemas.microsoft.com/office/drawing/2016/SVG/main" r:embed="R7ee8c646e7824b54"/>
+                <asvg:svgBlip xmlns:asvg="http://schemas.microsoft.com/office/drawing/2016/SVG/main" r:embed="Rbbe11fcfb5a64941"/>
               </a:ext>
             </a:extLst>
           </a:blip>
@@ -18260,10 +18260,10 @@
           <p:nvPr/>
         </p:nvPicPr>
         <p:blipFill>
-          <a:blip xmlns:r="http://schemas.openxmlformats.org/officeDocument/2006/relationships" xmlns:a="http://schemas.openxmlformats.org/drawingml/2006/main" r:embed="R7ea833f4403b4802">
+          <a:blip xmlns:r="http://schemas.openxmlformats.org/officeDocument/2006/relationships" xmlns:a="http://schemas.openxmlformats.org/drawingml/2006/main" r:embed="Rd8bb989030cd4e45">
             <a:extLst>
               <a:ext uri="{96DAC541-7B7A-43D3-8B79-37D633B846F1}">
-                <asvg:svgBlip xmlns:asvg="http://schemas.microsoft.com/office/drawing/2016/SVG/main" r:embed="R5ec69858c08a4b90"/>
+                <asvg:svgBlip xmlns:asvg="http://schemas.microsoft.com/office/drawing/2016/SVG/main" r:embed="R21e264ec6fdf47d2"/>
               </a:ext>
             </a:extLst>
           </a:blip>
@@ -20688,10 +20688,10 @@
           <p:nvPr/>
         </p:nvPicPr>
         <p:blipFill>
-          <a:blip xmlns:r="http://schemas.openxmlformats.org/officeDocument/2006/relationships" xmlns:a="http://schemas.openxmlformats.org/drawingml/2006/main" r:embed="Rb4f52f67414a4628">
+          <a:blip xmlns:r="http://schemas.openxmlformats.org/officeDocument/2006/relationships" xmlns:a="http://schemas.openxmlformats.org/drawingml/2006/main" r:embed="R38624dfdcade466b">
             <a:extLst>
               <a:ext uri="{96DAC541-7B7A-43D3-8B79-37D633B846F1}">
-                <asvg:svgBlip xmlns:asvg="http://schemas.microsoft.com/office/drawing/2016/SVG/main" r:embed="R3ab73e8b96b44946"/>
+                <asvg:svgBlip xmlns:asvg="http://schemas.microsoft.com/office/drawing/2016/SVG/main" r:embed="R613e4aa936974a9b"/>
               </a:ext>
             </a:extLst>
           </a:blip>
@@ -21216,10 +21216,10 @@
           <p:nvPr/>
         </p:nvPicPr>
         <p:blipFill>
-          <a:blip xmlns:r="http://schemas.openxmlformats.org/officeDocument/2006/relationships" xmlns:a="http://schemas.openxmlformats.org/drawingml/2006/main" r:embed="R20a30e6fc9074c84">
+          <a:blip xmlns:r="http://schemas.openxmlformats.org/officeDocument/2006/relationships" xmlns:a="http://schemas.openxmlformats.org/drawingml/2006/main" r:embed="Rab7b95eb752f43cb">
             <a:extLst>
               <a:ext uri="{96DAC541-7B7A-43D3-8B79-37D633B846F1}">
-                <asvg:svgBlip xmlns:asvg="http://schemas.microsoft.com/office/drawing/2016/SVG/main" r:embed="R8e4b48f4bd184247"/>
+                <asvg:svgBlip xmlns:asvg="http://schemas.microsoft.com/office/drawing/2016/SVG/main" r:embed="Rd204ceb30496468d"/>
               </a:ext>
             </a:extLst>
           </a:blip>
@@ -21330,7 +21330,7 @@
                 <a:ea typeface="Arial"/>
                 <a:cs typeface="Arial"/>
               </a:rPr>
-              <a:t>Assessment caps are verified after apply; production capacity follows an approved plan.</a:t>
+              <a:t>Assessment: EUR 5 alert budget. Production capacity follows an approved plan.</a:t>
             </a:r>
             <a:endParaRPr sz="1200"/>
           </a:p>

</xml_diff>